<commit_message>
Update samples and README - 25075960254
</commit_message>
<xml_diff>
--- a/samples/test_pptx.pptx
+++ b/samples/test_pptx.pptx
@@ -129,7 +129,7 @@
           <p:cNvPr id="2" name="Title 1">
             <a:extLst>
               <a:ext uri="{FF2B5EF4-FFF2-40B4-BE49-F238E27FC236}">
-                <a16:creationId xmlns:a16="http://schemas.microsoft.com/office/drawing/2014/main" id="{BDCB2534-1FCD-A6A7-2437-A5F2FEE3DE22}"/>
+                <a16:creationId xmlns:a16="http://schemas.microsoft.com/office/drawing/2014/main" id="{90C61838-42E6-69A1-DFD1-FEC2527F65E5}"/>
               </a:ext>
             </a:extLst>
           </p:cNvPr>
@@ -166,7 +166,7 @@
           <p:cNvPr id="3" name="Subtitle 2">
             <a:extLst>
               <a:ext uri="{FF2B5EF4-FFF2-40B4-BE49-F238E27FC236}">
-                <a16:creationId xmlns:a16="http://schemas.microsoft.com/office/drawing/2014/main" id="{258BBC1C-AA5B-E079-F1CD-0984B372223B}"/>
+                <a16:creationId xmlns:a16="http://schemas.microsoft.com/office/drawing/2014/main" id="{2BAFF06F-FBB2-42B2-1977-05170536AC1B}"/>
               </a:ext>
             </a:extLst>
           </p:cNvPr>
@@ -236,7 +236,7 @@
           <p:cNvPr id="4" name="Date Placeholder 3">
             <a:extLst>
               <a:ext uri="{FF2B5EF4-FFF2-40B4-BE49-F238E27FC236}">
-                <a16:creationId xmlns:a16="http://schemas.microsoft.com/office/drawing/2014/main" id="{0FF84438-0D85-F1E7-0F45-9512CA93F82C}"/>
+                <a16:creationId xmlns:a16="http://schemas.microsoft.com/office/drawing/2014/main" id="{F6AB109C-9208-18A6-FCD0-FF2A1C3F0E22}"/>
               </a:ext>
             </a:extLst>
           </p:cNvPr>
@@ -252,9 +252,9 @@
           <a:bodyPr/>
           <a:lstStyle/>
           <a:p>
-            <a:fld id="{CBB687F7-C49A-4855-9FDE-8079232C240D}" type="datetimeFigureOut">
+            <a:fld id="{8640AB0A-39C8-4D5F-8DB0-2D5859300311}" type="datetimeFigureOut">
               <a:rPr lang="en-US" smtClean="0"/>
-              <a:t>2/21/2026</a:t>
+              <a:t>3/16/2026</a:t>
             </a:fld>
             <a:endParaRPr lang="en-US"/>
           </a:p>
@@ -265,7 +265,7 @@
           <p:cNvPr id="5" name="Footer Placeholder 4">
             <a:extLst>
               <a:ext uri="{FF2B5EF4-FFF2-40B4-BE49-F238E27FC236}">
-                <a16:creationId xmlns:a16="http://schemas.microsoft.com/office/drawing/2014/main" id="{ED0FB286-5209-6068-3577-1DBD13B606B9}"/>
+                <a16:creationId xmlns:a16="http://schemas.microsoft.com/office/drawing/2014/main" id="{2705124A-0B16-5220-01FB-A2858F1D7A42}"/>
               </a:ext>
             </a:extLst>
           </p:cNvPr>
@@ -290,7 +290,7 @@
           <p:cNvPr id="6" name="Slide Number Placeholder 5">
             <a:extLst>
               <a:ext uri="{FF2B5EF4-FFF2-40B4-BE49-F238E27FC236}">
-                <a16:creationId xmlns:a16="http://schemas.microsoft.com/office/drawing/2014/main" id="{5FA6EBC3-AEFE-104E-47AF-34FDAED10C21}"/>
+                <a16:creationId xmlns:a16="http://schemas.microsoft.com/office/drawing/2014/main" id="{53E1BE64-7D32-3A64-6D16-B69D75C4C157}"/>
               </a:ext>
             </a:extLst>
           </p:cNvPr>
@@ -306,7 +306,7 @@
           <a:bodyPr/>
           <a:lstStyle/>
           <a:p>
-            <a:fld id="{C67D69EA-156E-4BAB-A371-A4BF45380129}" type="slidenum">
+            <a:fld id="{9361F2F8-A3CD-4E9D-9B45-AA7ACC7DECEC}" type="slidenum">
               <a:rPr lang="en-US" smtClean="0"/>
               <a:t>‹#›</a:t>
             </a:fld>
@@ -317,7 +317,7 @@
     </p:spTree>
     <p:extLst>
       <p:ext uri="{BB962C8B-B14F-4D97-AF65-F5344CB8AC3E}">
-        <p14:creationId xmlns:p14="http://schemas.microsoft.com/office/powerpoint/2010/main" val="2431666674"/>
+        <p14:creationId xmlns:p14="http://schemas.microsoft.com/office/powerpoint/2010/main" val="3420887599"/>
       </p:ext>
     </p:extLst>
   </p:cSld>
@@ -349,7 +349,7 @@
           <p:cNvPr id="2" name="Title 1">
             <a:extLst>
               <a:ext uri="{FF2B5EF4-FFF2-40B4-BE49-F238E27FC236}">
-                <a16:creationId xmlns:a16="http://schemas.microsoft.com/office/drawing/2014/main" id="{51E89E1F-0980-4B9C-4653-CB3AE7C598DE}"/>
+                <a16:creationId xmlns:a16="http://schemas.microsoft.com/office/drawing/2014/main" id="{17EED93A-230D-1AAF-2515-1B0E14B3C633}"/>
               </a:ext>
             </a:extLst>
           </p:cNvPr>
@@ -377,7 +377,7 @@
           <p:cNvPr id="3" name="Vertical Text Placeholder 2">
             <a:extLst>
               <a:ext uri="{FF2B5EF4-FFF2-40B4-BE49-F238E27FC236}">
-                <a16:creationId xmlns:a16="http://schemas.microsoft.com/office/drawing/2014/main" id="{54920584-B833-97DC-B6C5-BC4AC8AD6AD9}"/>
+                <a16:creationId xmlns:a16="http://schemas.microsoft.com/office/drawing/2014/main" id="{A21DFA35-DF1C-BFBF-9896-A8BB73D4D676}"/>
               </a:ext>
             </a:extLst>
           </p:cNvPr>
@@ -434,7 +434,7 @@
           <p:cNvPr id="4" name="Date Placeholder 3">
             <a:extLst>
               <a:ext uri="{FF2B5EF4-FFF2-40B4-BE49-F238E27FC236}">
-                <a16:creationId xmlns:a16="http://schemas.microsoft.com/office/drawing/2014/main" id="{3B0F7E50-35C9-F59E-7B91-ADDC891071FB}"/>
+                <a16:creationId xmlns:a16="http://schemas.microsoft.com/office/drawing/2014/main" id="{0AAFC8B6-CC01-CC6C-78DA-07E4A621CEC1}"/>
               </a:ext>
             </a:extLst>
           </p:cNvPr>
@@ -450,9 +450,9 @@
           <a:bodyPr/>
           <a:lstStyle/>
           <a:p>
-            <a:fld id="{CBB687F7-C49A-4855-9FDE-8079232C240D}" type="datetimeFigureOut">
+            <a:fld id="{8640AB0A-39C8-4D5F-8DB0-2D5859300311}" type="datetimeFigureOut">
               <a:rPr lang="en-US" smtClean="0"/>
-              <a:t>2/21/2026</a:t>
+              <a:t>3/16/2026</a:t>
             </a:fld>
             <a:endParaRPr lang="en-US"/>
           </a:p>
@@ -463,7 +463,7 @@
           <p:cNvPr id="5" name="Footer Placeholder 4">
             <a:extLst>
               <a:ext uri="{FF2B5EF4-FFF2-40B4-BE49-F238E27FC236}">
-                <a16:creationId xmlns:a16="http://schemas.microsoft.com/office/drawing/2014/main" id="{7EBECBAF-F86C-F750-1D4E-6CD5399038EB}"/>
+                <a16:creationId xmlns:a16="http://schemas.microsoft.com/office/drawing/2014/main" id="{C95B5967-911C-01B1-D194-0804B2AAF388}"/>
               </a:ext>
             </a:extLst>
           </p:cNvPr>
@@ -488,7 +488,7 @@
           <p:cNvPr id="6" name="Slide Number Placeholder 5">
             <a:extLst>
               <a:ext uri="{FF2B5EF4-FFF2-40B4-BE49-F238E27FC236}">
-                <a16:creationId xmlns:a16="http://schemas.microsoft.com/office/drawing/2014/main" id="{DBC6FE35-A9CB-0DAB-A807-F0C1C8D41AF5}"/>
+                <a16:creationId xmlns:a16="http://schemas.microsoft.com/office/drawing/2014/main" id="{71A82601-796D-0C16-F181-74F21C4215F1}"/>
               </a:ext>
             </a:extLst>
           </p:cNvPr>
@@ -504,7 +504,7 @@
           <a:bodyPr/>
           <a:lstStyle/>
           <a:p>
-            <a:fld id="{C67D69EA-156E-4BAB-A371-A4BF45380129}" type="slidenum">
+            <a:fld id="{9361F2F8-A3CD-4E9D-9B45-AA7ACC7DECEC}" type="slidenum">
               <a:rPr lang="en-US" smtClean="0"/>
               <a:t>‹#›</a:t>
             </a:fld>
@@ -515,7 +515,7 @@
     </p:spTree>
     <p:extLst>
       <p:ext uri="{BB962C8B-B14F-4D97-AF65-F5344CB8AC3E}">
-        <p14:creationId xmlns:p14="http://schemas.microsoft.com/office/powerpoint/2010/main" val="1581098979"/>
+        <p14:creationId xmlns:p14="http://schemas.microsoft.com/office/powerpoint/2010/main" val="4086877408"/>
       </p:ext>
     </p:extLst>
   </p:cSld>
@@ -547,7 +547,7 @@
           <p:cNvPr id="2" name="Vertical Title 1">
             <a:extLst>
               <a:ext uri="{FF2B5EF4-FFF2-40B4-BE49-F238E27FC236}">
-                <a16:creationId xmlns:a16="http://schemas.microsoft.com/office/drawing/2014/main" id="{F1721E3D-5214-74A6-CBD0-44CB7B0DD527}"/>
+                <a16:creationId xmlns:a16="http://schemas.microsoft.com/office/drawing/2014/main" id="{166B2BDC-4A15-8113-0F45-4090971D714E}"/>
               </a:ext>
             </a:extLst>
           </p:cNvPr>
@@ -580,7 +580,7 @@
           <p:cNvPr id="3" name="Vertical Text Placeholder 2">
             <a:extLst>
               <a:ext uri="{FF2B5EF4-FFF2-40B4-BE49-F238E27FC236}">
-                <a16:creationId xmlns:a16="http://schemas.microsoft.com/office/drawing/2014/main" id="{B3E3E17D-2AD2-70DD-8D5E-87B954159BAC}"/>
+                <a16:creationId xmlns:a16="http://schemas.microsoft.com/office/drawing/2014/main" id="{A610259D-EA48-58BA-2D49-3F6695041B69}"/>
               </a:ext>
             </a:extLst>
           </p:cNvPr>
@@ -642,7 +642,7 @@
           <p:cNvPr id="4" name="Date Placeholder 3">
             <a:extLst>
               <a:ext uri="{FF2B5EF4-FFF2-40B4-BE49-F238E27FC236}">
-                <a16:creationId xmlns:a16="http://schemas.microsoft.com/office/drawing/2014/main" id="{D5B9286C-01BE-26A1-6E94-CB364BA82DB1}"/>
+                <a16:creationId xmlns:a16="http://schemas.microsoft.com/office/drawing/2014/main" id="{5CA55CC3-2A48-B4B0-2C17-E3C376B09FE9}"/>
               </a:ext>
             </a:extLst>
           </p:cNvPr>
@@ -658,9 +658,9 @@
           <a:bodyPr/>
           <a:lstStyle/>
           <a:p>
-            <a:fld id="{CBB687F7-C49A-4855-9FDE-8079232C240D}" type="datetimeFigureOut">
+            <a:fld id="{8640AB0A-39C8-4D5F-8DB0-2D5859300311}" type="datetimeFigureOut">
               <a:rPr lang="en-US" smtClean="0"/>
-              <a:t>2/21/2026</a:t>
+              <a:t>3/16/2026</a:t>
             </a:fld>
             <a:endParaRPr lang="en-US"/>
           </a:p>
@@ -671,7 +671,7 @@
           <p:cNvPr id="5" name="Footer Placeholder 4">
             <a:extLst>
               <a:ext uri="{FF2B5EF4-FFF2-40B4-BE49-F238E27FC236}">
-                <a16:creationId xmlns:a16="http://schemas.microsoft.com/office/drawing/2014/main" id="{94BF24CE-D1D1-81E4-1956-81394F03B85E}"/>
+                <a16:creationId xmlns:a16="http://schemas.microsoft.com/office/drawing/2014/main" id="{987956FB-D43B-9254-D84F-D5F259992FEB}"/>
               </a:ext>
             </a:extLst>
           </p:cNvPr>
@@ -696,7 +696,7 @@
           <p:cNvPr id="6" name="Slide Number Placeholder 5">
             <a:extLst>
               <a:ext uri="{FF2B5EF4-FFF2-40B4-BE49-F238E27FC236}">
-                <a16:creationId xmlns:a16="http://schemas.microsoft.com/office/drawing/2014/main" id="{8D8D8070-3E16-7D2F-3CB3-8D6CAD843FCA}"/>
+                <a16:creationId xmlns:a16="http://schemas.microsoft.com/office/drawing/2014/main" id="{6B53F844-8DA3-E580-945B-B0818B2E4EFA}"/>
               </a:ext>
             </a:extLst>
           </p:cNvPr>
@@ -712,7 +712,7 @@
           <a:bodyPr/>
           <a:lstStyle/>
           <a:p>
-            <a:fld id="{C67D69EA-156E-4BAB-A371-A4BF45380129}" type="slidenum">
+            <a:fld id="{9361F2F8-A3CD-4E9D-9B45-AA7ACC7DECEC}" type="slidenum">
               <a:rPr lang="en-US" smtClean="0"/>
               <a:t>‹#›</a:t>
             </a:fld>
@@ -723,7 +723,7 @@
     </p:spTree>
     <p:extLst>
       <p:ext uri="{BB962C8B-B14F-4D97-AF65-F5344CB8AC3E}">
-        <p14:creationId xmlns:p14="http://schemas.microsoft.com/office/powerpoint/2010/main" val="2003180323"/>
+        <p14:creationId xmlns:p14="http://schemas.microsoft.com/office/powerpoint/2010/main" val="2870412579"/>
       </p:ext>
     </p:extLst>
   </p:cSld>
@@ -755,7 +755,7 @@
           <p:cNvPr id="2" name="Title 1">
             <a:extLst>
               <a:ext uri="{FF2B5EF4-FFF2-40B4-BE49-F238E27FC236}">
-                <a16:creationId xmlns:a16="http://schemas.microsoft.com/office/drawing/2014/main" id="{5F507A48-3E5B-4BC0-E1FB-CB14CD9AA2F2}"/>
+                <a16:creationId xmlns:a16="http://schemas.microsoft.com/office/drawing/2014/main" id="{E0CFC717-6322-CF80-326C-8A29B171CF82}"/>
               </a:ext>
             </a:extLst>
           </p:cNvPr>
@@ -783,7 +783,7 @@
           <p:cNvPr id="3" name="Content Placeholder 2">
             <a:extLst>
               <a:ext uri="{FF2B5EF4-FFF2-40B4-BE49-F238E27FC236}">
-                <a16:creationId xmlns:a16="http://schemas.microsoft.com/office/drawing/2014/main" id="{B555E15F-325A-B4D0-9902-8D5F2E3CBA76}"/>
+                <a16:creationId xmlns:a16="http://schemas.microsoft.com/office/drawing/2014/main" id="{C7736629-BB67-D845-6158-A336B5C21BCF}"/>
               </a:ext>
             </a:extLst>
           </p:cNvPr>
@@ -840,7 +840,7 @@
           <p:cNvPr id="4" name="Date Placeholder 3">
             <a:extLst>
               <a:ext uri="{FF2B5EF4-FFF2-40B4-BE49-F238E27FC236}">
-                <a16:creationId xmlns:a16="http://schemas.microsoft.com/office/drawing/2014/main" id="{174935FE-4356-8923-52B1-0D9EAF1E4485}"/>
+                <a16:creationId xmlns:a16="http://schemas.microsoft.com/office/drawing/2014/main" id="{095813D6-F6CC-C9AD-EF98-8906F515F92D}"/>
               </a:ext>
             </a:extLst>
           </p:cNvPr>
@@ -856,9 +856,9 @@
           <a:bodyPr/>
           <a:lstStyle/>
           <a:p>
-            <a:fld id="{CBB687F7-C49A-4855-9FDE-8079232C240D}" type="datetimeFigureOut">
+            <a:fld id="{8640AB0A-39C8-4D5F-8DB0-2D5859300311}" type="datetimeFigureOut">
               <a:rPr lang="en-US" smtClean="0"/>
-              <a:t>2/21/2026</a:t>
+              <a:t>3/16/2026</a:t>
             </a:fld>
             <a:endParaRPr lang="en-US"/>
           </a:p>
@@ -869,7 +869,7 @@
           <p:cNvPr id="5" name="Footer Placeholder 4">
             <a:extLst>
               <a:ext uri="{FF2B5EF4-FFF2-40B4-BE49-F238E27FC236}">
-                <a16:creationId xmlns:a16="http://schemas.microsoft.com/office/drawing/2014/main" id="{E980A260-2FB4-A91D-5AB7-35B715DE5104}"/>
+                <a16:creationId xmlns:a16="http://schemas.microsoft.com/office/drawing/2014/main" id="{5D35A646-6C84-4575-F859-5242E07AB8C7}"/>
               </a:ext>
             </a:extLst>
           </p:cNvPr>
@@ -894,7 +894,7 @@
           <p:cNvPr id="6" name="Slide Number Placeholder 5">
             <a:extLst>
               <a:ext uri="{FF2B5EF4-FFF2-40B4-BE49-F238E27FC236}">
-                <a16:creationId xmlns:a16="http://schemas.microsoft.com/office/drawing/2014/main" id="{AB04C35A-C4F7-7006-EFFD-1B8A5ED7E85C}"/>
+                <a16:creationId xmlns:a16="http://schemas.microsoft.com/office/drawing/2014/main" id="{8E92DDB4-5343-1871-CBA5-715BBEFF5160}"/>
               </a:ext>
             </a:extLst>
           </p:cNvPr>
@@ -910,7 +910,7 @@
           <a:bodyPr/>
           <a:lstStyle/>
           <a:p>
-            <a:fld id="{C67D69EA-156E-4BAB-A371-A4BF45380129}" type="slidenum">
+            <a:fld id="{9361F2F8-A3CD-4E9D-9B45-AA7ACC7DECEC}" type="slidenum">
               <a:rPr lang="en-US" smtClean="0"/>
               <a:t>‹#›</a:t>
             </a:fld>
@@ -921,7 +921,7 @@
     </p:spTree>
     <p:extLst>
       <p:ext uri="{BB962C8B-B14F-4D97-AF65-F5344CB8AC3E}">
-        <p14:creationId xmlns:p14="http://schemas.microsoft.com/office/powerpoint/2010/main" val="241425838"/>
+        <p14:creationId xmlns:p14="http://schemas.microsoft.com/office/powerpoint/2010/main" val="3282230454"/>
       </p:ext>
     </p:extLst>
   </p:cSld>
@@ -953,7 +953,7 @@
           <p:cNvPr id="2" name="Title 1">
             <a:extLst>
               <a:ext uri="{FF2B5EF4-FFF2-40B4-BE49-F238E27FC236}">
-                <a16:creationId xmlns:a16="http://schemas.microsoft.com/office/drawing/2014/main" id="{714A8F32-ABC6-E3D9-2010-120386A900EE}"/>
+                <a16:creationId xmlns:a16="http://schemas.microsoft.com/office/drawing/2014/main" id="{EBC5CC28-BF9D-63BF-9FCF-9524195925E4}"/>
               </a:ext>
             </a:extLst>
           </p:cNvPr>
@@ -990,7 +990,7 @@
           <p:cNvPr id="3" name="Text Placeholder 2">
             <a:extLst>
               <a:ext uri="{FF2B5EF4-FFF2-40B4-BE49-F238E27FC236}">
-                <a16:creationId xmlns:a16="http://schemas.microsoft.com/office/drawing/2014/main" id="{8799838C-8826-0956-889C-B090867FFBF7}"/>
+                <a16:creationId xmlns:a16="http://schemas.microsoft.com/office/drawing/2014/main" id="{A901E8C3-ABBB-9A87-827F-482BAE268913}"/>
               </a:ext>
             </a:extLst>
           </p:cNvPr>
@@ -1115,7 +1115,7 @@
           <p:cNvPr id="4" name="Date Placeholder 3">
             <a:extLst>
               <a:ext uri="{FF2B5EF4-FFF2-40B4-BE49-F238E27FC236}">
-                <a16:creationId xmlns:a16="http://schemas.microsoft.com/office/drawing/2014/main" id="{C2D8BD0F-365C-1202-2055-178D989DE3D8}"/>
+                <a16:creationId xmlns:a16="http://schemas.microsoft.com/office/drawing/2014/main" id="{2FA19CA2-5FAF-1498-CED5-3B2B89F4D22E}"/>
               </a:ext>
             </a:extLst>
           </p:cNvPr>
@@ -1131,9 +1131,9 @@
           <a:bodyPr/>
           <a:lstStyle/>
           <a:p>
-            <a:fld id="{CBB687F7-C49A-4855-9FDE-8079232C240D}" type="datetimeFigureOut">
+            <a:fld id="{8640AB0A-39C8-4D5F-8DB0-2D5859300311}" type="datetimeFigureOut">
               <a:rPr lang="en-US" smtClean="0"/>
-              <a:t>2/21/2026</a:t>
+              <a:t>3/16/2026</a:t>
             </a:fld>
             <a:endParaRPr lang="en-US"/>
           </a:p>
@@ -1144,7 +1144,7 @@
           <p:cNvPr id="5" name="Footer Placeholder 4">
             <a:extLst>
               <a:ext uri="{FF2B5EF4-FFF2-40B4-BE49-F238E27FC236}">
-                <a16:creationId xmlns:a16="http://schemas.microsoft.com/office/drawing/2014/main" id="{9FA0181B-B790-D169-9C5C-7741796EBFEC}"/>
+                <a16:creationId xmlns:a16="http://schemas.microsoft.com/office/drawing/2014/main" id="{F5B42823-DE81-87BF-1F42-0A971240F371}"/>
               </a:ext>
             </a:extLst>
           </p:cNvPr>
@@ -1169,7 +1169,7 @@
           <p:cNvPr id="6" name="Slide Number Placeholder 5">
             <a:extLst>
               <a:ext uri="{FF2B5EF4-FFF2-40B4-BE49-F238E27FC236}">
-                <a16:creationId xmlns:a16="http://schemas.microsoft.com/office/drawing/2014/main" id="{B313CF54-CF1E-F80A-1240-AF743B2A0265}"/>
+                <a16:creationId xmlns:a16="http://schemas.microsoft.com/office/drawing/2014/main" id="{394C6665-DA37-B035-A9D3-F8B874D366A0}"/>
               </a:ext>
             </a:extLst>
           </p:cNvPr>
@@ -1185,7 +1185,7 @@
           <a:bodyPr/>
           <a:lstStyle/>
           <a:p>
-            <a:fld id="{C67D69EA-156E-4BAB-A371-A4BF45380129}" type="slidenum">
+            <a:fld id="{9361F2F8-A3CD-4E9D-9B45-AA7ACC7DECEC}" type="slidenum">
               <a:rPr lang="en-US" smtClean="0"/>
               <a:t>‹#›</a:t>
             </a:fld>
@@ -1196,7 +1196,7 @@
     </p:spTree>
     <p:extLst>
       <p:ext uri="{BB962C8B-B14F-4D97-AF65-F5344CB8AC3E}">
-        <p14:creationId xmlns:p14="http://schemas.microsoft.com/office/powerpoint/2010/main" val="1217373211"/>
+        <p14:creationId xmlns:p14="http://schemas.microsoft.com/office/powerpoint/2010/main" val="2261606617"/>
       </p:ext>
     </p:extLst>
   </p:cSld>
@@ -1228,7 +1228,7 @@
           <p:cNvPr id="2" name="Title 1">
             <a:extLst>
               <a:ext uri="{FF2B5EF4-FFF2-40B4-BE49-F238E27FC236}">
-                <a16:creationId xmlns:a16="http://schemas.microsoft.com/office/drawing/2014/main" id="{F33F37C2-F1D5-8C02-43E5-039B0A7AAEAC}"/>
+                <a16:creationId xmlns:a16="http://schemas.microsoft.com/office/drawing/2014/main" id="{9963EFD0-28B4-B972-152C-A486D60EFFB3}"/>
               </a:ext>
             </a:extLst>
           </p:cNvPr>
@@ -1256,7 +1256,7 @@
           <p:cNvPr id="3" name="Content Placeholder 2">
             <a:extLst>
               <a:ext uri="{FF2B5EF4-FFF2-40B4-BE49-F238E27FC236}">
-                <a16:creationId xmlns:a16="http://schemas.microsoft.com/office/drawing/2014/main" id="{FF04A62F-42C3-7074-E8A6-676F2DA1432C}"/>
+                <a16:creationId xmlns:a16="http://schemas.microsoft.com/office/drawing/2014/main" id="{24F7880F-F514-4588-13CD-402FA909AAED}"/>
               </a:ext>
             </a:extLst>
           </p:cNvPr>
@@ -1318,7 +1318,7 @@
           <p:cNvPr id="4" name="Content Placeholder 3">
             <a:extLst>
               <a:ext uri="{FF2B5EF4-FFF2-40B4-BE49-F238E27FC236}">
-                <a16:creationId xmlns:a16="http://schemas.microsoft.com/office/drawing/2014/main" id="{28B525D8-4085-A730-25D9-A20DCDE334D3}"/>
+                <a16:creationId xmlns:a16="http://schemas.microsoft.com/office/drawing/2014/main" id="{04890AEC-F639-7CB3-9DE0-F904279E69A1}"/>
               </a:ext>
             </a:extLst>
           </p:cNvPr>
@@ -1380,7 +1380,7 @@
           <p:cNvPr id="5" name="Date Placeholder 4">
             <a:extLst>
               <a:ext uri="{FF2B5EF4-FFF2-40B4-BE49-F238E27FC236}">
-                <a16:creationId xmlns:a16="http://schemas.microsoft.com/office/drawing/2014/main" id="{2EAF86BD-FDCA-8BF3-F94A-7E50C41CCA5D}"/>
+                <a16:creationId xmlns:a16="http://schemas.microsoft.com/office/drawing/2014/main" id="{59017B0C-2339-9271-64B9-C3D9E1C33977}"/>
               </a:ext>
             </a:extLst>
           </p:cNvPr>
@@ -1396,9 +1396,9 @@
           <a:bodyPr/>
           <a:lstStyle/>
           <a:p>
-            <a:fld id="{CBB687F7-C49A-4855-9FDE-8079232C240D}" type="datetimeFigureOut">
+            <a:fld id="{8640AB0A-39C8-4D5F-8DB0-2D5859300311}" type="datetimeFigureOut">
               <a:rPr lang="en-US" smtClean="0"/>
-              <a:t>2/21/2026</a:t>
+              <a:t>3/16/2026</a:t>
             </a:fld>
             <a:endParaRPr lang="en-US"/>
           </a:p>
@@ -1409,7 +1409,7 @@
           <p:cNvPr id="6" name="Footer Placeholder 5">
             <a:extLst>
               <a:ext uri="{FF2B5EF4-FFF2-40B4-BE49-F238E27FC236}">
-                <a16:creationId xmlns:a16="http://schemas.microsoft.com/office/drawing/2014/main" id="{929BBCFA-480E-9EBD-C71F-3936E908E3DF}"/>
+                <a16:creationId xmlns:a16="http://schemas.microsoft.com/office/drawing/2014/main" id="{150DF103-51DE-2867-8BCE-EB5B7BA92B8B}"/>
               </a:ext>
             </a:extLst>
           </p:cNvPr>
@@ -1434,7 +1434,7 @@
           <p:cNvPr id="7" name="Slide Number Placeholder 6">
             <a:extLst>
               <a:ext uri="{FF2B5EF4-FFF2-40B4-BE49-F238E27FC236}">
-                <a16:creationId xmlns:a16="http://schemas.microsoft.com/office/drawing/2014/main" id="{229D9DB2-861C-965B-1DD0-64F565FD6748}"/>
+                <a16:creationId xmlns:a16="http://schemas.microsoft.com/office/drawing/2014/main" id="{95A6D8C5-39E7-A028-4E4A-73741FFB2086}"/>
               </a:ext>
             </a:extLst>
           </p:cNvPr>
@@ -1450,7 +1450,7 @@
           <a:bodyPr/>
           <a:lstStyle/>
           <a:p>
-            <a:fld id="{C67D69EA-156E-4BAB-A371-A4BF45380129}" type="slidenum">
+            <a:fld id="{9361F2F8-A3CD-4E9D-9B45-AA7ACC7DECEC}" type="slidenum">
               <a:rPr lang="en-US" smtClean="0"/>
               <a:t>‹#›</a:t>
             </a:fld>
@@ -1461,7 +1461,7 @@
     </p:spTree>
     <p:extLst>
       <p:ext uri="{BB962C8B-B14F-4D97-AF65-F5344CB8AC3E}">
-        <p14:creationId xmlns:p14="http://schemas.microsoft.com/office/powerpoint/2010/main" val="2727555287"/>
+        <p14:creationId xmlns:p14="http://schemas.microsoft.com/office/powerpoint/2010/main" val="1662414381"/>
       </p:ext>
     </p:extLst>
   </p:cSld>
@@ -1493,7 +1493,7 @@
           <p:cNvPr id="2" name="Title 1">
             <a:extLst>
               <a:ext uri="{FF2B5EF4-FFF2-40B4-BE49-F238E27FC236}">
-                <a16:creationId xmlns:a16="http://schemas.microsoft.com/office/drawing/2014/main" id="{67ED3F07-E1E4-5ABC-D1D0-ECCF18D276C9}"/>
+                <a16:creationId xmlns:a16="http://schemas.microsoft.com/office/drawing/2014/main" id="{7FCE11C3-F0E4-8255-B00D-A966A8A8E9CA}"/>
               </a:ext>
             </a:extLst>
           </p:cNvPr>
@@ -1526,7 +1526,7 @@
           <p:cNvPr id="3" name="Text Placeholder 2">
             <a:extLst>
               <a:ext uri="{FF2B5EF4-FFF2-40B4-BE49-F238E27FC236}">
-                <a16:creationId xmlns:a16="http://schemas.microsoft.com/office/drawing/2014/main" id="{7B827901-D039-AC3A-15CC-AE328DFCF614}"/>
+                <a16:creationId xmlns:a16="http://schemas.microsoft.com/office/drawing/2014/main" id="{D7883732-0F37-A765-D9C6-EDF68EF10244}"/>
               </a:ext>
             </a:extLst>
           </p:cNvPr>
@@ -1597,7 +1597,7 @@
           <p:cNvPr id="4" name="Content Placeholder 3">
             <a:extLst>
               <a:ext uri="{FF2B5EF4-FFF2-40B4-BE49-F238E27FC236}">
-                <a16:creationId xmlns:a16="http://schemas.microsoft.com/office/drawing/2014/main" id="{3E95C3E8-88A1-3929-119E-D50DC3E3408A}"/>
+                <a16:creationId xmlns:a16="http://schemas.microsoft.com/office/drawing/2014/main" id="{66BFD4B5-FB58-935C-89C8-EBC538219CA5}"/>
               </a:ext>
             </a:extLst>
           </p:cNvPr>
@@ -1659,7 +1659,7 @@
           <p:cNvPr id="5" name="Text Placeholder 4">
             <a:extLst>
               <a:ext uri="{FF2B5EF4-FFF2-40B4-BE49-F238E27FC236}">
-                <a16:creationId xmlns:a16="http://schemas.microsoft.com/office/drawing/2014/main" id="{17AD0B58-4F2D-493E-9B52-8B32AF39622C}"/>
+                <a16:creationId xmlns:a16="http://schemas.microsoft.com/office/drawing/2014/main" id="{A46AF1A7-4CC8-9573-268B-46836FCD7148}"/>
               </a:ext>
             </a:extLst>
           </p:cNvPr>
@@ -1730,7 +1730,7 @@
           <p:cNvPr id="6" name="Content Placeholder 5">
             <a:extLst>
               <a:ext uri="{FF2B5EF4-FFF2-40B4-BE49-F238E27FC236}">
-                <a16:creationId xmlns:a16="http://schemas.microsoft.com/office/drawing/2014/main" id="{65D43803-A721-2229-72CA-83E280E9CF78}"/>
+                <a16:creationId xmlns:a16="http://schemas.microsoft.com/office/drawing/2014/main" id="{5B06C50D-0DB3-8FB5-4885-D3E3089752D9}"/>
               </a:ext>
             </a:extLst>
           </p:cNvPr>
@@ -1792,7 +1792,7 @@
           <p:cNvPr id="7" name="Date Placeholder 6">
             <a:extLst>
               <a:ext uri="{FF2B5EF4-FFF2-40B4-BE49-F238E27FC236}">
-                <a16:creationId xmlns:a16="http://schemas.microsoft.com/office/drawing/2014/main" id="{227E1312-12EC-50CF-6A6D-DD3E79205DF0}"/>
+                <a16:creationId xmlns:a16="http://schemas.microsoft.com/office/drawing/2014/main" id="{1ECF00F0-5E96-543D-F0D8-D587990C8409}"/>
               </a:ext>
             </a:extLst>
           </p:cNvPr>
@@ -1808,9 +1808,9 @@
           <a:bodyPr/>
           <a:lstStyle/>
           <a:p>
-            <a:fld id="{CBB687F7-C49A-4855-9FDE-8079232C240D}" type="datetimeFigureOut">
+            <a:fld id="{8640AB0A-39C8-4D5F-8DB0-2D5859300311}" type="datetimeFigureOut">
               <a:rPr lang="en-US" smtClean="0"/>
-              <a:t>2/21/2026</a:t>
+              <a:t>3/16/2026</a:t>
             </a:fld>
             <a:endParaRPr lang="en-US"/>
           </a:p>
@@ -1821,7 +1821,7 @@
           <p:cNvPr id="8" name="Footer Placeholder 7">
             <a:extLst>
               <a:ext uri="{FF2B5EF4-FFF2-40B4-BE49-F238E27FC236}">
-                <a16:creationId xmlns:a16="http://schemas.microsoft.com/office/drawing/2014/main" id="{5BB99B7B-39EF-F292-0052-7FD33B971B88}"/>
+                <a16:creationId xmlns:a16="http://schemas.microsoft.com/office/drawing/2014/main" id="{9236252E-7CB7-D51D-33C0-BA8E6D70EB7A}"/>
               </a:ext>
             </a:extLst>
           </p:cNvPr>
@@ -1846,7 +1846,7 @@
           <p:cNvPr id="9" name="Slide Number Placeholder 8">
             <a:extLst>
               <a:ext uri="{FF2B5EF4-FFF2-40B4-BE49-F238E27FC236}">
-                <a16:creationId xmlns:a16="http://schemas.microsoft.com/office/drawing/2014/main" id="{02957533-E169-7A85-3A3B-6FA017715C5B}"/>
+                <a16:creationId xmlns:a16="http://schemas.microsoft.com/office/drawing/2014/main" id="{C4E87D6B-90FE-FFC8-7CA7-664C0D8DCAF5}"/>
               </a:ext>
             </a:extLst>
           </p:cNvPr>
@@ -1862,7 +1862,7 @@
           <a:bodyPr/>
           <a:lstStyle/>
           <a:p>
-            <a:fld id="{C67D69EA-156E-4BAB-A371-A4BF45380129}" type="slidenum">
+            <a:fld id="{9361F2F8-A3CD-4E9D-9B45-AA7ACC7DECEC}" type="slidenum">
               <a:rPr lang="en-US" smtClean="0"/>
               <a:t>‹#›</a:t>
             </a:fld>
@@ -1873,7 +1873,7 @@
     </p:spTree>
     <p:extLst>
       <p:ext uri="{BB962C8B-B14F-4D97-AF65-F5344CB8AC3E}">
-        <p14:creationId xmlns:p14="http://schemas.microsoft.com/office/powerpoint/2010/main" val="3963058309"/>
+        <p14:creationId xmlns:p14="http://schemas.microsoft.com/office/powerpoint/2010/main" val="3347981107"/>
       </p:ext>
     </p:extLst>
   </p:cSld>
@@ -1905,7 +1905,7 @@
           <p:cNvPr id="2" name="Title 1">
             <a:extLst>
               <a:ext uri="{FF2B5EF4-FFF2-40B4-BE49-F238E27FC236}">
-                <a16:creationId xmlns:a16="http://schemas.microsoft.com/office/drawing/2014/main" id="{D8FE581C-3D2A-346E-FD50-E21E44D6D952}"/>
+                <a16:creationId xmlns:a16="http://schemas.microsoft.com/office/drawing/2014/main" id="{B96C9DAA-1B45-21E4-3A98-674A66993F52}"/>
               </a:ext>
             </a:extLst>
           </p:cNvPr>
@@ -1933,7 +1933,7 @@
           <p:cNvPr id="3" name="Date Placeholder 2">
             <a:extLst>
               <a:ext uri="{FF2B5EF4-FFF2-40B4-BE49-F238E27FC236}">
-                <a16:creationId xmlns:a16="http://schemas.microsoft.com/office/drawing/2014/main" id="{3E18F9BD-E4CB-8757-FE8E-F4E158B0D248}"/>
+                <a16:creationId xmlns:a16="http://schemas.microsoft.com/office/drawing/2014/main" id="{1F1775A7-E949-F39A-11E4-36CD5FF9DC1C}"/>
               </a:ext>
             </a:extLst>
           </p:cNvPr>
@@ -1949,9 +1949,9 @@
           <a:bodyPr/>
           <a:lstStyle/>
           <a:p>
-            <a:fld id="{CBB687F7-C49A-4855-9FDE-8079232C240D}" type="datetimeFigureOut">
+            <a:fld id="{8640AB0A-39C8-4D5F-8DB0-2D5859300311}" type="datetimeFigureOut">
               <a:rPr lang="en-US" smtClean="0"/>
-              <a:t>2/21/2026</a:t>
+              <a:t>3/16/2026</a:t>
             </a:fld>
             <a:endParaRPr lang="en-US"/>
           </a:p>
@@ -1962,7 +1962,7 @@
           <p:cNvPr id="4" name="Footer Placeholder 3">
             <a:extLst>
               <a:ext uri="{FF2B5EF4-FFF2-40B4-BE49-F238E27FC236}">
-                <a16:creationId xmlns:a16="http://schemas.microsoft.com/office/drawing/2014/main" id="{AAB1B5EF-3CCF-D9BD-0E84-E8C0A858C37F}"/>
+                <a16:creationId xmlns:a16="http://schemas.microsoft.com/office/drawing/2014/main" id="{A4376571-3D10-A398-4A36-29A591FC3206}"/>
               </a:ext>
             </a:extLst>
           </p:cNvPr>
@@ -1987,7 +1987,7 @@
           <p:cNvPr id="5" name="Slide Number Placeholder 4">
             <a:extLst>
               <a:ext uri="{FF2B5EF4-FFF2-40B4-BE49-F238E27FC236}">
-                <a16:creationId xmlns:a16="http://schemas.microsoft.com/office/drawing/2014/main" id="{E5CD48CD-32DD-AA5C-9185-40F147169FB7}"/>
+                <a16:creationId xmlns:a16="http://schemas.microsoft.com/office/drawing/2014/main" id="{74C26E88-7918-1A32-B57F-B89323FD92C3}"/>
               </a:ext>
             </a:extLst>
           </p:cNvPr>
@@ -2003,7 +2003,7 @@
           <a:bodyPr/>
           <a:lstStyle/>
           <a:p>
-            <a:fld id="{C67D69EA-156E-4BAB-A371-A4BF45380129}" type="slidenum">
+            <a:fld id="{9361F2F8-A3CD-4E9D-9B45-AA7ACC7DECEC}" type="slidenum">
               <a:rPr lang="en-US" smtClean="0"/>
               <a:t>‹#›</a:t>
             </a:fld>
@@ -2014,7 +2014,7 @@
     </p:spTree>
     <p:extLst>
       <p:ext uri="{BB962C8B-B14F-4D97-AF65-F5344CB8AC3E}">
-        <p14:creationId xmlns:p14="http://schemas.microsoft.com/office/powerpoint/2010/main" val="1269455626"/>
+        <p14:creationId xmlns:p14="http://schemas.microsoft.com/office/powerpoint/2010/main" val="3147313033"/>
       </p:ext>
     </p:extLst>
   </p:cSld>
@@ -2046,7 +2046,7 @@
           <p:cNvPr id="2" name="Date Placeholder 1">
             <a:extLst>
               <a:ext uri="{FF2B5EF4-FFF2-40B4-BE49-F238E27FC236}">
-                <a16:creationId xmlns:a16="http://schemas.microsoft.com/office/drawing/2014/main" id="{8E75B8CD-7372-C370-034D-97D18C1278A6}"/>
+                <a16:creationId xmlns:a16="http://schemas.microsoft.com/office/drawing/2014/main" id="{E7677752-4AA7-E700-D835-6217E4A92CEC}"/>
               </a:ext>
             </a:extLst>
           </p:cNvPr>
@@ -2062,9 +2062,9 @@
           <a:bodyPr/>
           <a:lstStyle/>
           <a:p>
-            <a:fld id="{CBB687F7-C49A-4855-9FDE-8079232C240D}" type="datetimeFigureOut">
+            <a:fld id="{8640AB0A-39C8-4D5F-8DB0-2D5859300311}" type="datetimeFigureOut">
               <a:rPr lang="en-US" smtClean="0"/>
-              <a:t>2/21/2026</a:t>
+              <a:t>3/16/2026</a:t>
             </a:fld>
             <a:endParaRPr lang="en-US"/>
           </a:p>
@@ -2075,7 +2075,7 @@
           <p:cNvPr id="3" name="Footer Placeholder 2">
             <a:extLst>
               <a:ext uri="{FF2B5EF4-FFF2-40B4-BE49-F238E27FC236}">
-                <a16:creationId xmlns:a16="http://schemas.microsoft.com/office/drawing/2014/main" id="{EBF6D176-304B-B34C-758A-9FA5D732BC7F}"/>
+                <a16:creationId xmlns:a16="http://schemas.microsoft.com/office/drawing/2014/main" id="{E97008B9-5DF4-5828-4FFD-26B110F782FB}"/>
               </a:ext>
             </a:extLst>
           </p:cNvPr>
@@ -2100,7 +2100,7 @@
           <p:cNvPr id="4" name="Slide Number Placeholder 3">
             <a:extLst>
               <a:ext uri="{FF2B5EF4-FFF2-40B4-BE49-F238E27FC236}">
-                <a16:creationId xmlns:a16="http://schemas.microsoft.com/office/drawing/2014/main" id="{325D41D8-9782-EE4C-5C23-E5710DB409EC}"/>
+                <a16:creationId xmlns:a16="http://schemas.microsoft.com/office/drawing/2014/main" id="{AC393CDC-AF31-EEB6-0DDF-42FF10330A27}"/>
               </a:ext>
             </a:extLst>
           </p:cNvPr>
@@ -2116,7 +2116,7 @@
           <a:bodyPr/>
           <a:lstStyle/>
           <a:p>
-            <a:fld id="{C67D69EA-156E-4BAB-A371-A4BF45380129}" type="slidenum">
+            <a:fld id="{9361F2F8-A3CD-4E9D-9B45-AA7ACC7DECEC}" type="slidenum">
               <a:rPr lang="en-US" smtClean="0"/>
               <a:t>‹#›</a:t>
             </a:fld>
@@ -2127,7 +2127,7 @@
     </p:spTree>
     <p:extLst>
       <p:ext uri="{BB962C8B-B14F-4D97-AF65-F5344CB8AC3E}">
-        <p14:creationId xmlns:p14="http://schemas.microsoft.com/office/powerpoint/2010/main" val="2935521768"/>
+        <p14:creationId xmlns:p14="http://schemas.microsoft.com/office/powerpoint/2010/main" val="2466160409"/>
       </p:ext>
     </p:extLst>
   </p:cSld>
@@ -2159,7 +2159,7 @@
           <p:cNvPr id="2" name="Title 1">
             <a:extLst>
               <a:ext uri="{FF2B5EF4-FFF2-40B4-BE49-F238E27FC236}">
-                <a16:creationId xmlns:a16="http://schemas.microsoft.com/office/drawing/2014/main" id="{70093402-19B3-8534-945B-5F635FB57DC3}"/>
+                <a16:creationId xmlns:a16="http://schemas.microsoft.com/office/drawing/2014/main" id="{DE38B238-5405-9912-1D05-9AFDB3F3B49A}"/>
               </a:ext>
             </a:extLst>
           </p:cNvPr>
@@ -2196,7 +2196,7 @@
           <p:cNvPr id="3" name="Content Placeholder 2">
             <a:extLst>
               <a:ext uri="{FF2B5EF4-FFF2-40B4-BE49-F238E27FC236}">
-                <a16:creationId xmlns:a16="http://schemas.microsoft.com/office/drawing/2014/main" id="{E1E5CA47-B8A2-0948-8730-EA3C958DFFDE}"/>
+                <a16:creationId xmlns:a16="http://schemas.microsoft.com/office/drawing/2014/main" id="{4D9742F2-3F92-D4C8-6767-D23208123BBB}"/>
               </a:ext>
             </a:extLst>
           </p:cNvPr>
@@ -2286,7 +2286,7 @@
           <p:cNvPr id="4" name="Text Placeholder 3">
             <a:extLst>
               <a:ext uri="{FF2B5EF4-FFF2-40B4-BE49-F238E27FC236}">
-                <a16:creationId xmlns:a16="http://schemas.microsoft.com/office/drawing/2014/main" id="{22BC1CC3-12AF-B29C-0488-FEE4038ACEAA}"/>
+                <a16:creationId xmlns:a16="http://schemas.microsoft.com/office/drawing/2014/main" id="{B942CE85-C101-08ED-292D-15BC07B920FD}"/>
               </a:ext>
             </a:extLst>
           </p:cNvPr>
@@ -2357,7 +2357,7 @@
           <p:cNvPr id="5" name="Date Placeholder 4">
             <a:extLst>
               <a:ext uri="{FF2B5EF4-FFF2-40B4-BE49-F238E27FC236}">
-                <a16:creationId xmlns:a16="http://schemas.microsoft.com/office/drawing/2014/main" id="{6BE8E900-24F4-E1D7-1B92-BDB16E73E739}"/>
+                <a16:creationId xmlns:a16="http://schemas.microsoft.com/office/drawing/2014/main" id="{997D5FD5-42A5-5A15-9886-C5DC101091E0}"/>
               </a:ext>
             </a:extLst>
           </p:cNvPr>
@@ -2373,9 +2373,9 @@
           <a:bodyPr/>
           <a:lstStyle/>
           <a:p>
-            <a:fld id="{CBB687F7-C49A-4855-9FDE-8079232C240D}" type="datetimeFigureOut">
+            <a:fld id="{8640AB0A-39C8-4D5F-8DB0-2D5859300311}" type="datetimeFigureOut">
               <a:rPr lang="en-US" smtClean="0"/>
-              <a:t>2/21/2026</a:t>
+              <a:t>3/16/2026</a:t>
             </a:fld>
             <a:endParaRPr lang="en-US"/>
           </a:p>
@@ -2386,7 +2386,7 @@
           <p:cNvPr id="6" name="Footer Placeholder 5">
             <a:extLst>
               <a:ext uri="{FF2B5EF4-FFF2-40B4-BE49-F238E27FC236}">
-                <a16:creationId xmlns:a16="http://schemas.microsoft.com/office/drawing/2014/main" id="{25011BCF-4DB4-354B-63A3-B2F66116E9B1}"/>
+                <a16:creationId xmlns:a16="http://schemas.microsoft.com/office/drawing/2014/main" id="{7FB61333-7004-60B6-0A8C-06236ACC975D}"/>
               </a:ext>
             </a:extLst>
           </p:cNvPr>
@@ -2411,7 +2411,7 @@
           <p:cNvPr id="7" name="Slide Number Placeholder 6">
             <a:extLst>
               <a:ext uri="{FF2B5EF4-FFF2-40B4-BE49-F238E27FC236}">
-                <a16:creationId xmlns:a16="http://schemas.microsoft.com/office/drawing/2014/main" id="{E014A084-EC02-396E-741A-6D161FB5575B}"/>
+                <a16:creationId xmlns:a16="http://schemas.microsoft.com/office/drawing/2014/main" id="{58B9A1CB-3B06-CA94-6D93-C56A995F7872}"/>
               </a:ext>
             </a:extLst>
           </p:cNvPr>
@@ -2427,7 +2427,7 @@
           <a:bodyPr/>
           <a:lstStyle/>
           <a:p>
-            <a:fld id="{C67D69EA-156E-4BAB-A371-A4BF45380129}" type="slidenum">
+            <a:fld id="{9361F2F8-A3CD-4E9D-9B45-AA7ACC7DECEC}" type="slidenum">
               <a:rPr lang="en-US" smtClean="0"/>
               <a:t>‹#›</a:t>
             </a:fld>
@@ -2438,7 +2438,7 @@
     </p:spTree>
     <p:extLst>
       <p:ext uri="{BB962C8B-B14F-4D97-AF65-F5344CB8AC3E}">
-        <p14:creationId xmlns:p14="http://schemas.microsoft.com/office/powerpoint/2010/main" val="1862328162"/>
+        <p14:creationId xmlns:p14="http://schemas.microsoft.com/office/powerpoint/2010/main" val="3234175938"/>
       </p:ext>
     </p:extLst>
   </p:cSld>
@@ -2470,7 +2470,7 @@
           <p:cNvPr id="2" name="Title 1">
             <a:extLst>
               <a:ext uri="{FF2B5EF4-FFF2-40B4-BE49-F238E27FC236}">
-                <a16:creationId xmlns:a16="http://schemas.microsoft.com/office/drawing/2014/main" id="{12802F15-233D-FB6C-A6C3-A7B909E6EEED}"/>
+                <a16:creationId xmlns:a16="http://schemas.microsoft.com/office/drawing/2014/main" id="{FEFEDB6D-71E8-5403-2C0F-FA4BF9E3428B}"/>
               </a:ext>
             </a:extLst>
           </p:cNvPr>
@@ -2507,7 +2507,7 @@
           <p:cNvPr id="3" name="Picture Placeholder 2">
             <a:extLst>
               <a:ext uri="{FF2B5EF4-FFF2-40B4-BE49-F238E27FC236}">
-                <a16:creationId xmlns:a16="http://schemas.microsoft.com/office/drawing/2014/main" id="{C8019FB9-5E52-678F-7F3B-FACB372C7D0F}"/>
+                <a16:creationId xmlns:a16="http://schemas.microsoft.com/office/drawing/2014/main" id="{65E85BD3-B55E-0BE5-6575-0312F1C45CEE}"/>
               </a:ext>
             </a:extLst>
           </p:cNvPr>
@@ -2574,7 +2574,7 @@
           <p:cNvPr id="4" name="Text Placeholder 3">
             <a:extLst>
               <a:ext uri="{FF2B5EF4-FFF2-40B4-BE49-F238E27FC236}">
-                <a16:creationId xmlns:a16="http://schemas.microsoft.com/office/drawing/2014/main" id="{F1BFF9C5-886F-5861-72BB-3AE1A5866BD1}"/>
+                <a16:creationId xmlns:a16="http://schemas.microsoft.com/office/drawing/2014/main" id="{253403D0-7154-6EE8-46B5-325200E827F0}"/>
               </a:ext>
             </a:extLst>
           </p:cNvPr>
@@ -2645,7 +2645,7 @@
           <p:cNvPr id="5" name="Date Placeholder 4">
             <a:extLst>
               <a:ext uri="{FF2B5EF4-FFF2-40B4-BE49-F238E27FC236}">
-                <a16:creationId xmlns:a16="http://schemas.microsoft.com/office/drawing/2014/main" id="{798709F1-FFAB-A88F-7FD4-F7DE1DC677CA}"/>
+                <a16:creationId xmlns:a16="http://schemas.microsoft.com/office/drawing/2014/main" id="{408950E0-8F5D-1BDC-BB48-E39328177D05}"/>
               </a:ext>
             </a:extLst>
           </p:cNvPr>
@@ -2661,9 +2661,9 @@
           <a:bodyPr/>
           <a:lstStyle/>
           <a:p>
-            <a:fld id="{CBB687F7-C49A-4855-9FDE-8079232C240D}" type="datetimeFigureOut">
+            <a:fld id="{8640AB0A-39C8-4D5F-8DB0-2D5859300311}" type="datetimeFigureOut">
               <a:rPr lang="en-US" smtClean="0"/>
-              <a:t>2/21/2026</a:t>
+              <a:t>3/16/2026</a:t>
             </a:fld>
             <a:endParaRPr lang="en-US"/>
           </a:p>
@@ -2674,7 +2674,7 @@
           <p:cNvPr id="6" name="Footer Placeholder 5">
             <a:extLst>
               <a:ext uri="{FF2B5EF4-FFF2-40B4-BE49-F238E27FC236}">
-                <a16:creationId xmlns:a16="http://schemas.microsoft.com/office/drawing/2014/main" id="{4AF3CFB7-2551-F409-CD5E-253276AD7F32}"/>
+                <a16:creationId xmlns:a16="http://schemas.microsoft.com/office/drawing/2014/main" id="{C599CDD3-93E5-F4F1-B2AA-039A546CF609}"/>
               </a:ext>
             </a:extLst>
           </p:cNvPr>
@@ -2699,7 +2699,7 @@
           <p:cNvPr id="7" name="Slide Number Placeholder 6">
             <a:extLst>
               <a:ext uri="{FF2B5EF4-FFF2-40B4-BE49-F238E27FC236}">
-                <a16:creationId xmlns:a16="http://schemas.microsoft.com/office/drawing/2014/main" id="{72545289-3D83-A325-64F4-E15E8F491255}"/>
+                <a16:creationId xmlns:a16="http://schemas.microsoft.com/office/drawing/2014/main" id="{C009E0F4-3C0C-0BBC-B834-7FD6FFA56D53}"/>
               </a:ext>
             </a:extLst>
           </p:cNvPr>
@@ -2715,7 +2715,7 @@
           <a:bodyPr/>
           <a:lstStyle/>
           <a:p>
-            <a:fld id="{C67D69EA-156E-4BAB-A371-A4BF45380129}" type="slidenum">
+            <a:fld id="{9361F2F8-A3CD-4E9D-9B45-AA7ACC7DECEC}" type="slidenum">
               <a:rPr lang="en-US" smtClean="0"/>
               <a:t>‹#›</a:t>
             </a:fld>
@@ -2726,7 +2726,7 @@
     </p:spTree>
     <p:extLst>
       <p:ext uri="{BB962C8B-B14F-4D97-AF65-F5344CB8AC3E}">
-        <p14:creationId xmlns:p14="http://schemas.microsoft.com/office/powerpoint/2010/main" val="3622670129"/>
+        <p14:creationId xmlns:p14="http://schemas.microsoft.com/office/powerpoint/2010/main" val="4073812504"/>
       </p:ext>
     </p:extLst>
   </p:cSld>
@@ -2763,7 +2763,7 @@
           <p:cNvPr id="2" name="Title Placeholder 1">
             <a:extLst>
               <a:ext uri="{FF2B5EF4-FFF2-40B4-BE49-F238E27FC236}">
-                <a16:creationId xmlns:a16="http://schemas.microsoft.com/office/drawing/2014/main" id="{90E09D6D-59AA-5540-68D7-601397920462}"/>
+                <a16:creationId xmlns:a16="http://schemas.microsoft.com/office/drawing/2014/main" id="{3F5DEC63-B449-B8DB-0F5E-773093C4988E}"/>
               </a:ext>
             </a:extLst>
           </p:cNvPr>
@@ -2801,7 +2801,7 @@
           <p:cNvPr id="3" name="Text Placeholder 2">
             <a:extLst>
               <a:ext uri="{FF2B5EF4-FFF2-40B4-BE49-F238E27FC236}">
-                <a16:creationId xmlns:a16="http://schemas.microsoft.com/office/drawing/2014/main" id="{E5A51964-5F89-403C-1B10-847793327EEE}"/>
+                <a16:creationId xmlns:a16="http://schemas.microsoft.com/office/drawing/2014/main" id="{F031EAD2-0822-ACF3-E7A9-D6D8034CC3FE}"/>
               </a:ext>
             </a:extLst>
           </p:cNvPr>
@@ -2868,7 +2868,7 @@
           <p:cNvPr id="4" name="Date Placeholder 3">
             <a:extLst>
               <a:ext uri="{FF2B5EF4-FFF2-40B4-BE49-F238E27FC236}">
-                <a16:creationId xmlns:a16="http://schemas.microsoft.com/office/drawing/2014/main" id="{D483A0F9-7A61-D119-EF5F-DB4F94B35ACA}"/>
+                <a16:creationId xmlns:a16="http://schemas.microsoft.com/office/drawing/2014/main" id="{B6763C2E-16FE-096C-E57F-4DB8DE328982}"/>
               </a:ext>
             </a:extLst>
           </p:cNvPr>
@@ -2902,9 +2902,9 @@
             </a:lvl1pPr>
           </a:lstStyle>
           <a:p>
-            <a:fld id="{CBB687F7-C49A-4855-9FDE-8079232C240D}" type="datetimeFigureOut">
+            <a:fld id="{8640AB0A-39C8-4D5F-8DB0-2D5859300311}" type="datetimeFigureOut">
               <a:rPr lang="en-US" smtClean="0"/>
-              <a:t>2/21/2026</a:t>
+              <a:t>3/16/2026</a:t>
             </a:fld>
             <a:endParaRPr lang="en-US"/>
           </a:p>
@@ -2915,7 +2915,7 @@
           <p:cNvPr id="5" name="Footer Placeholder 4">
             <a:extLst>
               <a:ext uri="{FF2B5EF4-FFF2-40B4-BE49-F238E27FC236}">
-                <a16:creationId xmlns:a16="http://schemas.microsoft.com/office/drawing/2014/main" id="{E19652B1-554D-D95B-C2D1-6356A84FAEFB}"/>
+                <a16:creationId xmlns:a16="http://schemas.microsoft.com/office/drawing/2014/main" id="{FE3EF6D6-1042-DA1A-0CDA-78ADE14ACDA0}"/>
               </a:ext>
             </a:extLst>
           </p:cNvPr>
@@ -2958,7 +2958,7 @@
           <p:cNvPr id="6" name="Slide Number Placeholder 5">
             <a:extLst>
               <a:ext uri="{FF2B5EF4-FFF2-40B4-BE49-F238E27FC236}">
-                <a16:creationId xmlns:a16="http://schemas.microsoft.com/office/drawing/2014/main" id="{6AA2967D-E2A0-07F8-6FB1-C0592A97A0B3}"/>
+                <a16:creationId xmlns:a16="http://schemas.microsoft.com/office/drawing/2014/main" id="{4F9A853E-11E9-EB42-7952-90179B5D1ACF}"/>
               </a:ext>
             </a:extLst>
           </p:cNvPr>
@@ -2992,7 +2992,7 @@
             </a:lvl1pPr>
           </a:lstStyle>
           <a:p>
-            <a:fld id="{C67D69EA-156E-4BAB-A371-A4BF45380129}" type="slidenum">
+            <a:fld id="{9361F2F8-A3CD-4E9D-9B45-AA7ACC7DECEC}" type="slidenum">
               <a:rPr lang="en-US" smtClean="0"/>
               <a:t>‹#›</a:t>
             </a:fld>
@@ -3003,7 +3003,7 @@
     </p:spTree>
     <p:extLst>
       <p:ext uri="{BB962C8B-B14F-4D97-AF65-F5344CB8AC3E}">
-        <p14:creationId xmlns:p14="http://schemas.microsoft.com/office/powerpoint/2010/main" val="954951235"/>
+        <p14:creationId xmlns:p14="http://schemas.microsoft.com/office/powerpoint/2010/main" val="3789377524"/>
       </p:ext>
     </p:extLst>
   </p:cSld>
@@ -3326,7 +3326,7 @@
           <p:cNvPr id="2" name="Title 1">
             <a:extLst>
               <a:ext uri="{FF2B5EF4-FFF2-40B4-BE49-F238E27FC236}">
-                <a16:creationId xmlns:a16="http://schemas.microsoft.com/office/drawing/2014/main" id="{D812382F-8E36-A04A-155D-9590C6633B07}"/>
+                <a16:creationId xmlns:a16="http://schemas.microsoft.com/office/drawing/2014/main" id="{55CC4000-CBDD-A192-427B-FCB8C93E92D5}"/>
               </a:ext>
             </a:extLst>
           </p:cNvPr>
@@ -3354,7 +3354,7 @@
           <p:cNvPr id="3" name="Content Placeholder 2">
             <a:extLst>
               <a:ext uri="{FF2B5EF4-FFF2-40B4-BE49-F238E27FC236}">
-                <a16:creationId xmlns:a16="http://schemas.microsoft.com/office/drawing/2014/main" id="{EB5B1E36-2675-AD57-24D5-E4FD9CE81231}"/>
+                <a16:creationId xmlns:a16="http://schemas.microsoft.com/office/drawing/2014/main" id="{74061AC4-A4DD-F994-A440-CFFD6F523762}"/>
               </a:ext>
             </a:extLst>
           </p:cNvPr>
@@ -3377,7 +3377,7 @@
     </p:spTree>
     <p:extLst>
       <p:ext uri="{BB962C8B-B14F-4D97-AF65-F5344CB8AC3E}">
-        <p14:creationId xmlns:p14="http://schemas.microsoft.com/office/powerpoint/2010/main" val="3163242225"/>
+        <p14:creationId xmlns:p14="http://schemas.microsoft.com/office/powerpoint/2010/main" val="4009141093"/>
       </p:ext>
     </p:extLst>
   </p:cSld>

</xml_diff>